<commit_message>
docs: point repo references to juangh123/streamvault.cash and regenerate deck
</commit_message>
<xml_diff>
--- a/docs/deck/StreamVault-BCH-Blaze-2026.pptx
+++ b/docs/deck/StreamVault-BCH-Blaze-2026.pptx
@@ -2,19 +2,19 @@
 <file path=ppt/presentation.xml><?xml version="1.0" encoding="utf-8"?>
 <p:presentation xmlns:p="http://schemas.openxmlformats.org/presentationml/2006/main">
   <p:sldMasterIdLst>
-    <p:sldMasterId xmlns:r="http://schemas.openxmlformats.org/officeDocument/2006/relationships" id="2147483648" r:id="R2db5bf9798004782"/>
+    <p:sldMasterId xmlns:r="http://schemas.openxmlformats.org/officeDocument/2006/relationships" id="2147483648" r:id="R78a565f1a4ff40da"/>
   </p:sldMasterIdLst>
   <p:notesMasterIdLst>
-    <p:notesMasterId xmlns:r="http://schemas.openxmlformats.org/officeDocument/2006/relationships" r:id="R8faed92699114dce"/>
+    <p:notesMasterId xmlns:r="http://schemas.openxmlformats.org/officeDocument/2006/relationships" r:id="Re90db1306db24594"/>
   </p:notesMasterIdLst>
   <p:sldIdLst>
-    <p:sldId xmlns:r="http://schemas.openxmlformats.org/officeDocument/2006/relationships" id="256" r:id="Rd7ca576529844da1"/>
-    <p:sldId xmlns:r="http://schemas.openxmlformats.org/officeDocument/2006/relationships" id="257" r:id="R68faaaf0b75f40c1"/>
-    <p:sldId xmlns:r="http://schemas.openxmlformats.org/officeDocument/2006/relationships" id="258" r:id="Raf6724a90d614b59"/>
-    <p:sldId xmlns:r="http://schemas.openxmlformats.org/officeDocument/2006/relationships" id="259" r:id="R923dee0259674c39"/>
-    <p:sldId xmlns:r="http://schemas.openxmlformats.org/officeDocument/2006/relationships" id="260" r:id="R7917ffe94a374d00"/>
-    <p:sldId xmlns:r="http://schemas.openxmlformats.org/officeDocument/2006/relationships" id="261" r:id="Reffdd5f489f94d3e"/>
-    <p:sldId xmlns:r="http://schemas.openxmlformats.org/officeDocument/2006/relationships" id="262" r:id="Ra47589bbf78e46d9"/>
+    <p:sldId xmlns:r="http://schemas.openxmlformats.org/officeDocument/2006/relationships" id="256" r:id="R78f564e1bde74c99"/>
+    <p:sldId xmlns:r="http://schemas.openxmlformats.org/officeDocument/2006/relationships" id="257" r:id="R14883d9f770e47ba"/>
+    <p:sldId xmlns:r="http://schemas.openxmlformats.org/officeDocument/2006/relationships" id="258" r:id="R2f8e7a5188b5496a"/>
+    <p:sldId xmlns:r="http://schemas.openxmlformats.org/officeDocument/2006/relationships" id="259" r:id="R512d17f61215472d"/>
+    <p:sldId xmlns:r="http://schemas.openxmlformats.org/officeDocument/2006/relationships" id="260" r:id="Rb3240e4271c24862"/>
+    <p:sldId xmlns:r="http://schemas.openxmlformats.org/officeDocument/2006/relationships" id="261" r:id="Rc61d8f8399b746ae"/>
+    <p:sldId xmlns:r="http://schemas.openxmlformats.org/officeDocument/2006/relationships" id="262" r:id="R24846a707e21402c"/>
   </p:sldIdLst>
   <p:sldSz cx="12192000" cy="6858000"/>
   <p:notesSz cx="6858000" cy="9144000"/>
@@ -887,7 +887,7 @@
           <p:cNvPr id="3" name="Title">
             <a:extLst xmlns:a="http://schemas.openxmlformats.org/drawingml/2006/main">
               <a:ext uri="{FF2B5EF4-FFF2-40B4-BE49-F238E27FC236}">
-                <a16:creationId xmlns:a16="http://schemas.microsoft.com/office/drawing/2014/main" id="{69393EFC-6E06-44CA-8C72-C9C046D12C01}"/>
+                <a16:creationId xmlns:a16="http://schemas.microsoft.com/office/drawing/2014/main" id="{C6530832-4712-47F1-AE9B-9C59052D2869}"/>
               </a:ext>
             </a:extLst>
           </p:cNvPr>
@@ -1044,7 +1044,7 @@
           <p:cNvPr id="2" name="Subtitle">
             <a:extLst xmlns:a="http://schemas.openxmlformats.org/drawingml/2006/main">
               <a:ext uri="{FF2B5EF4-FFF2-40B4-BE49-F238E27FC236}">
-                <a16:creationId xmlns:a16="http://schemas.microsoft.com/office/drawing/2014/main" id="{4A41C8C5-1808-4306-A79D-3212E84D6207}"/>
+                <a16:creationId xmlns:a16="http://schemas.microsoft.com/office/drawing/2014/main" id="{5C4B20D8-E894-4DF8-AA33-C22045D9DFE1}"/>
               </a:ext>
             </a:extLst>
           </p:cNvPr>
@@ -1218,7 +1218,7 @@
           <p:cNvPr id="2" name="Section title">
             <a:extLst xmlns:a="http://schemas.openxmlformats.org/drawingml/2006/main">
               <a:ext uri="{FF2B5EF4-FFF2-40B4-BE49-F238E27FC236}">
-                <a16:creationId xmlns:a16="http://schemas.microsoft.com/office/drawing/2014/main" id="{A8F814ED-C266-496B-8B85-0A2A423B621B}"/>
+                <a16:creationId xmlns:a16="http://schemas.microsoft.com/office/drawing/2014/main" id="{1319F0C3-B2D3-46D6-87DE-1F0968C24B78}"/>
               </a:ext>
             </a:extLst>
           </p:cNvPr>
@@ -1392,7 +1392,7 @@
           <p:cNvPr id="3" name="Title">
             <a:extLst xmlns:a="http://schemas.openxmlformats.org/drawingml/2006/main">
               <a:ext uri="{FF2B5EF4-FFF2-40B4-BE49-F238E27FC236}">
-                <a16:creationId xmlns:a16="http://schemas.microsoft.com/office/drawing/2014/main" id="{DA0CEC8F-BC3D-4FE7-B271-711D5CA6A45F}"/>
+                <a16:creationId xmlns:a16="http://schemas.microsoft.com/office/drawing/2014/main" id="{241E5175-C864-4C9C-99A3-09B4E287E7D2}"/>
               </a:ext>
             </a:extLst>
           </p:cNvPr>
@@ -1549,7 +1549,7 @@
           <p:cNvPr id="2" name="Body">
             <a:extLst xmlns:a="http://schemas.openxmlformats.org/drawingml/2006/main">
               <a:ext uri="{FF2B5EF4-FFF2-40B4-BE49-F238E27FC236}">
-                <a16:creationId xmlns:a16="http://schemas.microsoft.com/office/drawing/2014/main" id="{FD24280C-DC52-4B5D-A439-DEB96FB1A6BF}"/>
+                <a16:creationId xmlns:a16="http://schemas.microsoft.com/office/drawing/2014/main" id="{09626BCD-B798-4AFF-8169-A8EDD398B5E7}"/>
               </a:ext>
             </a:extLst>
           </p:cNvPr>
@@ -1723,7 +1723,7 @@
           <p:cNvPr id="4" name="Title">
             <a:extLst xmlns:a="http://schemas.openxmlformats.org/drawingml/2006/main">
               <a:ext uri="{FF2B5EF4-FFF2-40B4-BE49-F238E27FC236}">
-                <a16:creationId xmlns:a16="http://schemas.microsoft.com/office/drawing/2014/main" id="{55B6FDB4-F1A0-458E-8321-07510FABFC34}"/>
+                <a16:creationId xmlns:a16="http://schemas.microsoft.com/office/drawing/2014/main" id="{C073BB25-0653-4A1D-8FB1-CBC52C60B4BD}"/>
               </a:ext>
             </a:extLst>
           </p:cNvPr>
@@ -1880,7 +1880,7 @@
           <p:cNvPr id="2" name="Left column">
             <a:extLst xmlns:a="http://schemas.openxmlformats.org/drawingml/2006/main">
               <a:ext uri="{FF2B5EF4-FFF2-40B4-BE49-F238E27FC236}">
-                <a16:creationId xmlns:a16="http://schemas.microsoft.com/office/drawing/2014/main" id="{66EA58E2-D1DC-471A-8730-C3E3395DB005}"/>
+                <a16:creationId xmlns:a16="http://schemas.microsoft.com/office/drawing/2014/main" id="{431FDD08-16F7-4CD3-9E2B-F9D914979A65}"/>
               </a:ext>
             </a:extLst>
           </p:cNvPr>
@@ -2037,7 +2037,7 @@
           <p:cNvPr id="3" name="Right column">
             <a:extLst xmlns:a="http://schemas.openxmlformats.org/drawingml/2006/main">
               <a:ext uri="{FF2B5EF4-FFF2-40B4-BE49-F238E27FC236}">
-                <a16:creationId xmlns:a16="http://schemas.microsoft.com/office/drawing/2014/main" id="{3617AA9E-1D71-4A0E-BF72-63111A284F2E}"/>
+                <a16:creationId xmlns:a16="http://schemas.microsoft.com/office/drawing/2014/main" id="{707C37A6-B2CE-4F27-B51B-CC8C3C482EB9}"/>
               </a:ext>
             </a:extLst>
           </p:cNvPr>
@@ -2211,7 +2211,7 @@
           <p:cNvPr id="3" name="Title">
             <a:extLst xmlns:a="http://schemas.openxmlformats.org/drawingml/2006/main">
               <a:ext uri="{FF2B5EF4-FFF2-40B4-BE49-F238E27FC236}">
-                <a16:creationId xmlns:a16="http://schemas.microsoft.com/office/drawing/2014/main" id="{3AD2C2A4-0AC3-4263-821D-2F847A78EE43}"/>
+                <a16:creationId xmlns:a16="http://schemas.microsoft.com/office/drawing/2014/main" id="{E387B255-3B74-45F0-9A4A-79E07BE3EC9F}"/>
               </a:ext>
             </a:extLst>
           </p:cNvPr>
@@ -2368,7 +2368,7 @@
           <p:cNvPr id="2" name="Left column">
             <a:extLst xmlns:a="http://schemas.openxmlformats.org/drawingml/2006/main">
               <a:ext uri="{FF2B5EF4-FFF2-40B4-BE49-F238E27FC236}">
-                <a16:creationId xmlns:a16="http://schemas.microsoft.com/office/drawing/2014/main" id="{E3369494-BF78-4ADB-95BE-7204F2E8618B}"/>
+                <a16:creationId xmlns:a16="http://schemas.microsoft.com/office/drawing/2014/main" id="{C506ECFB-35AF-4A82-9D8C-C53FDBCB32A9}"/>
               </a:ext>
             </a:extLst>
           </p:cNvPr>
@@ -2563,12 +2563,12 @@
   </p:cSld>
   <p:clrMap bg1="lt1" tx1="dk1" bg2="lt2" tx2="dk2" accent1="accent1" accent2="accent2" accent3="accent3" accent4="accent4" accent5="accent5" accent6="accent6" hlink="hlink" folHlink="folHlink"/>
   <p:sldLayoutIdLst>
-    <p:sldLayoutId xmlns:r="http://schemas.openxmlformats.org/officeDocument/2006/relationships" id="2147483649" r:id="R4b141b26b2aa44d9"/>
-    <p:sldLayoutId xmlns:r="http://schemas.openxmlformats.org/officeDocument/2006/relationships" id="2147483650" r:id="R96122bd521b14dd3"/>
-    <p:sldLayoutId xmlns:r="http://schemas.openxmlformats.org/officeDocument/2006/relationships" id="2147483651" r:id="Rc212eb71af804c03"/>
-    <p:sldLayoutId xmlns:r="http://schemas.openxmlformats.org/officeDocument/2006/relationships" id="2147483652" r:id="R54bb3a7fd05e46ee"/>
-    <p:sldLayoutId xmlns:r="http://schemas.openxmlformats.org/officeDocument/2006/relationships" id="2147483653" r:id="R6043162ca53740d9"/>
-    <p:sldLayoutId xmlns:r="http://schemas.openxmlformats.org/officeDocument/2006/relationships" id="2147483654" r:id="R4c628ed6af2641b8"/>
+    <p:sldLayoutId xmlns:r="http://schemas.openxmlformats.org/officeDocument/2006/relationships" id="2147483649" r:id="R892d7bcf54004835"/>
+    <p:sldLayoutId xmlns:r="http://schemas.openxmlformats.org/officeDocument/2006/relationships" id="2147483650" r:id="Ra698d2c5f9aa4dd7"/>
+    <p:sldLayoutId xmlns:r="http://schemas.openxmlformats.org/officeDocument/2006/relationships" id="2147483651" r:id="Rc907ad9c648042da"/>
+    <p:sldLayoutId xmlns:r="http://schemas.openxmlformats.org/officeDocument/2006/relationships" id="2147483652" r:id="Raeb9d7c699924275"/>
+    <p:sldLayoutId xmlns:r="http://schemas.openxmlformats.org/officeDocument/2006/relationships" id="2147483653" r:id="Ra4896faca168459b"/>
+    <p:sldLayoutId xmlns:r="http://schemas.openxmlformats.org/officeDocument/2006/relationships" id="2147483654" r:id="Re8a80b20bddb44e7"/>
   </p:sldLayoutIdLst>
   <p:txStyles>
     <p:titleStyle>
@@ -3119,7 +3119,7 @@
           <p:cNvPr id="10" name="">
             <a:extLst xmlns:a="http://schemas.openxmlformats.org/drawingml/2006/main">
               <a:ext uri="{FF2B5EF4-FFF2-40B4-BE49-F238E27FC236}">
-                <a16:creationId xmlns:a16="http://schemas.microsoft.com/office/drawing/2014/main" id="{97BDEBD8-7C8A-49C0-8302-5686A8F0391C}"/>
+                <a16:creationId xmlns:a16="http://schemas.microsoft.com/office/drawing/2014/main" id="{6DC408E5-5EC7-4602-BCE0-548C5E0CF7A6}"/>
               </a:ext>
             </a:extLst>
           </p:cNvPr>
@@ -3177,7 +3177,7 @@
           <p:cNvPr id="2" name="">
             <a:extLst xmlns:a="http://schemas.openxmlformats.org/drawingml/2006/main">
               <a:ext uri="{FF2B5EF4-FFF2-40B4-BE49-F238E27FC236}">
-                <a16:creationId xmlns:a16="http://schemas.microsoft.com/office/drawing/2014/main" id="{347F4EF4-9325-4153-B716-F1D00A830024}"/>
+                <a16:creationId xmlns:a16="http://schemas.microsoft.com/office/drawing/2014/main" id="{955762BD-F871-4E01-8DE5-D020E280595B}"/>
               </a:ext>
             </a:extLst>
           </p:cNvPr>
@@ -3235,7 +3235,7 @@
           <p:cNvPr id="3" name="">
             <a:extLst xmlns:a="http://schemas.openxmlformats.org/drawingml/2006/main">
               <a:ext uri="{FF2B5EF4-FFF2-40B4-BE49-F238E27FC236}">
-                <a16:creationId xmlns:a16="http://schemas.microsoft.com/office/drawing/2014/main" id="{7A2445DD-FEE0-4BAF-B0C4-2ADF2977045F}"/>
+                <a16:creationId xmlns:a16="http://schemas.microsoft.com/office/drawing/2014/main" id="{23390D7E-296E-4226-9B01-D785F5186B0A}"/>
               </a:ext>
             </a:extLst>
           </p:cNvPr>
@@ -3293,7 +3293,7 @@
           <p:cNvPr id="4" name="">
             <a:extLst xmlns:a="http://schemas.openxmlformats.org/drawingml/2006/main">
               <a:ext uri="{FF2B5EF4-FFF2-40B4-BE49-F238E27FC236}">
-                <a16:creationId xmlns:a16="http://schemas.microsoft.com/office/drawing/2014/main" id="{2C7340FE-8AC5-4867-A245-B2618FAFAD68}"/>
+                <a16:creationId xmlns:a16="http://schemas.microsoft.com/office/drawing/2014/main" id="{CD4A4A9A-735D-405E-B81F-E033680ACB86}"/>
               </a:ext>
             </a:extLst>
           </p:cNvPr>
@@ -3351,7 +3351,7 @@
           <p:cNvPr id="5" name="">
             <a:extLst xmlns:a="http://schemas.openxmlformats.org/drawingml/2006/main">
               <a:ext uri="{FF2B5EF4-FFF2-40B4-BE49-F238E27FC236}">
-                <a16:creationId xmlns:a16="http://schemas.microsoft.com/office/drawing/2014/main" id="{98060BF7-828F-4B5E-804D-C7E49400156C}"/>
+                <a16:creationId xmlns:a16="http://schemas.microsoft.com/office/drawing/2014/main" id="{9D18F786-E4DC-4EE4-AB55-E47939E02001}"/>
               </a:ext>
             </a:extLst>
           </p:cNvPr>
@@ -3386,7 +3386,7 @@
           <p:cNvPr id="6" name="">
             <a:extLst xmlns:a="http://schemas.openxmlformats.org/drawingml/2006/main">
               <a:ext uri="{FF2B5EF4-FFF2-40B4-BE49-F238E27FC236}">
-                <a16:creationId xmlns:a16="http://schemas.microsoft.com/office/drawing/2014/main" id="{B131686E-B919-4FC2-AE14-E5E5EE71473F}"/>
+                <a16:creationId xmlns:a16="http://schemas.microsoft.com/office/drawing/2014/main" id="{7F64893D-7E3D-4393-B985-52DDFC370C38}"/>
               </a:ext>
             </a:extLst>
           </p:cNvPr>
@@ -3444,7 +3444,7 @@
           <p:cNvPr id="7" name="">
             <a:extLst xmlns:a="http://schemas.openxmlformats.org/drawingml/2006/main">
               <a:ext uri="{FF2B5EF4-FFF2-40B4-BE49-F238E27FC236}">
-                <a16:creationId xmlns:a16="http://schemas.microsoft.com/office/drawing/2014/main" id="{CE714665-0499-43FC-93F1-E0FDD895E918}"/>
+                <a16:creationId xmlns:a16="http://schemas.microsoft.com/office/drawing/2014/main" id="{40427998-FA4F-4BBF-9939-F3A779C56B1B}"/>
               </a:ext>
             </a:extLst>
           </p:cNvPr>
@@ -3502,7 +3502,7 @@
           <p:cNvPr id="8" name="">
             <a:extLst xmlns:a="http://schemas.openxmlformats.org/drawingml/2006/main">
               <a:ext uri="{FF2B5EF4-FFF2-40B4-BE49-F238E27FC236}">
-                <a16:creationId xmlns:a16="http://schemas.microsoft.com/office/drawing/2014/main" id="{9A4396BC-A570-40D7-A50C-2EF34FB17F50}"/>
+                <a16:creationId xmlns:a16="http://schemas.microsoft.com/office/drawing/2014/main" id="{4F432D94-7FBB-4B70-9669-2E04EA5BED0A}"/>
               </a:ext>
             </a:extLst>
           </p:cNvPr>
@@ -3560,7 +3560,7 @@
           <p:cNvPr id="9" name="">
             <a:extLst xmlns:a="http://schemas.openxmlformats.org/drawingml/2006/main">
               <a:ext uri="{FF2B5EF4-FFF2-40B4-BE49-F238E27FC236}">
-                <a16:creationId xmlns:a16="http://schemas.microsoft.com/office/drawing/2014/main" id="{E0CC2F34-66C0-427C-88AF-A10C49A81C22}"/>
+                <a16:creationId xmlns:a16="http://schemas.microsoft.com/office/drawing/2014/main" id="{84DCAF20-74A4-46A3-A9ED-3BFC19FBFFC4}"/>
               </a:ext>
             </a:extLst>
           </p:cNvPr>
@@ -3616,7 +3616,7 @@
     </p:spTree>
     <p:extLst>
       <p:ext uri="{BB962C8B-B14F-4D97-AF65-F5344CB8AC3E}">
-        <p14:creationId xmlns:p14="http://schemas.microsoft.com/office/powerpoint/2010/main" val="1303417725"/>
+        <p14:creationId xmlns:p14="http://schemas.microsoft.com/office/powerpoint/2010/main" val="1283098994"/>
       </p:ext>
     </p:extLst>
   </p:cSld>
@@ -3647,7 +3647,7 @@
           <p:cNvPr id="13" name="">
             <a:extLst xmlns:a="http://schemas.openxmlformats.org/drawingml/2006/main">
               <a:ext uri="{FF2B5EF4-FFF2-40B4-BE49-F238E27FC236}">
-                <a16:creationId xmlns:a16="http://schemas.microsoft.com/office/drawing/2014/main" id="{874D9E03-DBD7-4726-BE05-870F17CD4F9F}"/>
+                <a16:creationId xmlns:a16="http://schemas.microsoft.com/office/drawing/2014/main" id="{2505EA11-C3C2-4892-87B5-7D1FB73E2311}"/>
               </a:ext>
             </a:extLst>
           </p:cNvPr>
@@ -3705,7 +3705,7 @@
           <p:cNvPr id="2" name="">
             <a:extLst xmlns:a="http://schemas.openxmlformats.org/drawingml/2006/main">
               <a:ext uri="{FF2B5EF4-FFF2-40B4-BE49-F238E27FC236}">
-                <a16:creationId xmlns:a16="http://schemas.microsoft.com/office/drawing/2014/main" id="{DBF11312-A7BE-4C49-B6EA-CD5772DAA56E}"/>
+                <a16:creationId xmlns:a16="http://schemas.microsoft.com/office/drawing/2014/main" id="{1D971093-2BA7-4183-A9C8-B7B9562C8042}"/>
               </a:ext>
             </a:extLst>
           </p:cNvPr>
@@ -3763,7 +3763,7 @@
           <p:cNvPr id="3" name="">
             <a:extLst xmlns:a="http://schemas.openxmlformats.org/drawingml/2006/main">
               <a:ext uri="{FF2B5EF4-FFF2-40B4-BE49-F238E27FC236}">
-                <a16:creationId xmlns:a16="http://schemas.microsoft.com/office/drawing/2014/main" id="{3FBFEB38-8D53-41A0-B082-BA6A9F329290}"/>
+                <a16:creationId xmlns:a16="http://schemas.microsoft.com/office/drawing/2014/main" id="{B65AB2F7-32AE-44C7-83AC-1739F3CE0D5C}"/>
               </a:ext>
             </a:extLst>
           </p:cNvPr>
@@ -3798,7 +3798,7 @@
           <p:cNvPr id="4" name="">
             <a:extLst xmlns:a="http://schemas.openxmlformats.org/drawingml/2006/main">
               <a:ext uri="{FF2B5EF4-FFF2-40B4-BE49-F238E27FC236}">
-                <a16:creationId xmlns:a16="http://schemas.microsoft.com/office/drawing/2014/main" id="{B21E312B-647F-4A29-9A79-CD13931E47E3}"/>
+                <a16:creationId xmlns:a16="http://schemas.microsoft.com/office/drawing/2014/main" id="{F670D9DA-E33F-40E0-ABF6-2FC116175638}"/>
               </a:ext>
             </a:extLst>
           </p:cNvPr>
@@ -3856,7 +3856,7 @@
           <p:cNvPr id="5" name="">
             <a:extLst xmlns:a="http://schemas.openxmlformats.org/drawingml/2006/main">
               <a:ext uri="{FF2B5EF4-FFF2-40B4-BE49-F238E27FC236}">
-                <a16:creationId xmlns:a16="http://schemas.microsoft.com/office/drawing/2014/main" id="{CA053EFA-E6CE-42F5-ADE7-5B20EA496637}"/>
+                <a16:creationId xmlns:a16="http://schemas.microsoft.com/office/drawing/2014/main" id="{C130C72E-322E-488C-9582-8D54F8432CF4}"/>
               </a:ext>
             </a:extLst>
           </p:cNvPr>
@@ -3914,7 +3914,7 @@
           <p:cNvPr id="6" name="">
             <a:extLst xmlns:a="http://schemas.openxmlformats.org/drawingml/2006/main">
               <a:ext uri="{FF2B5EF4-FFF2-40B4-BE49-F238E27FC236}">
-                <a16:creationId xmlns:a16="http://schemas.microsoft.com/office/drawing/2014/main" id="{4324327C-6E45-4635-82D4-E93871A8CBDE}"/>
+                <a16:creationId xmlns:a16="http://schemas.microsoft.com/office/drawing/2014/main" id="{EA092D5C-DDBE-4CE2-BBAA-853AE73D1F6C}"/>
               </a:ext>
             </a:extLst>
           </p:cNvPr>
@@ -3949,7 +3949,7 @@
           <p:cNvPr id="7" name="">
             <a:extLst xmlns:a="http://schemas.openxmlformats.org/drawingml/2006/main">
               <a:ext uri="{FF2B5EF4-FFF2-40B4-BE49-F238E27FC236}">
-                <a16:creationId xmlns:a16="http://schemas.microsoft.com/office/drawing/2014/main" id="{13B58F94-E097-4BD6-913D-FE04F6A3F8FD}"/>
+                <a16:creationId xmlns:a16="http://schemas.microsoft.com/office/drawing/2014/main" id="{673B97BA-9261-4B2B-9621-798E262550AC}"/>
               </a:ext>
             </a:extLst>
           </p:cNvPr>
@@ -4007,7 +4007,7 @@
           <p:cNvPr id="8" name="">
             <a:extLst xmlns:a="http://schemas.openxmlformats.org/drawingml/2006/main">
               <a:ext uri="{FF2B5EF4-FFF2-40B4-BE49-F238E27FC236}">
-                <a16:creationId xmlns:a16="http://schemas.microsoft.com/office/drawing/2014/main" id="{79716BF5-2224-4C1C-83CE-72B4D4D8ED19}"/>
+                <a16:creationId xmlns:a16="http://schemas.microsoft.com/office/drawing/2014/main" id="{F950F84D-D282-4E61-B328-DF844812D31A}"/>
               </a:ext>
             </a:extLst>
           </p:cNvPr>
@@ -4065,7 +4065,7 @@
           <p:cNvPr id="9" name="">
             <a:extLst xmlns:a="http://schemas.openxmlformats.org/drawingml/2006/main">
               <a:ext uri="{FF2B5EF4-FFF2-40B4-BE49-F238E27FC236}">
-                <a16:creationId xmlns:a16="http://schemas.microsoft.com/office/drawing/2014/main" id="{FFA50143-E7BC-4186-B4C3-FD13D1FDA39D}"/>
+                <a16:creationId xmlns:a16="http://schemas.microsoft.com/office/drawing/2014/main" id="{44FDB0CB-AAFE-4698-BD42-71877677338E}"/>
               </a:ext>
             </a:extLst>
           </p:cNvPr>
@@ -4100,7 +4100,7 @@
           <p:cNvPr id="10" name="">
             <a:extLst xmlns:a="http://schemas.openxmlformats.org/drawingml/2006/main">
               <a:ext uri="{FF2B5EF4-FFF2-40B4-BE49-F238E27FC236}">
-                <a16:creationId xmlns:a16="http://schemas.microsoft.com/office/drawing/2014/main" id="{059EF8F5-1C8F-4885-A90C-A9ECA772BF53}"/>
+                <a16:creationId xmlns:a16="http://schemas.microsoft.com/office/drawing/2014/main" id="{6A87F1B3-18D2-4356-8410-A185E321E779}"/>
               </a:ext>
             </a:extLst>
           </p:cNvPr>
@@ -4158,7 +4158,7 @@
           <p:cNvPr id="11" name="">
             <a:extLst xmlns:a="http://schemas.openxmlformats.org/drawingml/2006/main">
               <a:ext uri="{FF2B5EF4-FFF2-40B4-BE49-F238E27FC236}">
-                <a16:creationId xmlns:a16="http://schemas.microsoft.com/office/drawing/2014/main" id="{FF291A43-8B92-448A-A6DA-DDD5D01BFD80}"/>
+                <a16:creationId xmlns:a16="http://schemas.microsoft.com/office/drawing/2014/main" id="{EDD34E56-0013-4DFA-AD07-C8EDAFB4A475}"/>
               </a:ext>
             </a:extLst>
           </p:cNvPr>
@@ -4216,7 +4216,7 @@
           <p:cNvPr id="12" name="">
             <a:extLst xmlns:a="http://schemas.openxmlformats.org/drawingml/2006/main">
               <a:ext uri="{FF2B5EF4-FFF2-40B4-BE49-F238E27FC236}">
-                <a16:creationId xmlns:a16="http://schemas.microsoft.com/office/drawing/2014/main" id="{FC530293-DD27-481C-B73E-2A78AE8743A5}"/>
+                <a16:creationId xmlns:a16="http://schemas.microsoft.com/office/drawing/2014/main" id="{5DE8B242-9BC3-44CD-B1C8-5B906C745174}"/>
               </a:ext>
             </a:extLst>
           </p:cNvPr>
@@ -4264,7 +4264,7 @@
                   <a:srgbClr val="94A3B8"/>
                 </a:solidFill>
               </a:rPr>
-              <a:t>github.com/streamvault/streamvault.cash</a:t>
+              <a:t>github.com/juangh123/streamvault.cash</a:t>
             </a:r>
           </a:p>
         </p:txBody>
@@ -4272,7 +4272,7 @@
     </p:spTree>
     <p:extLst>
       <p:ext uri="{BB962C8B-B14F-4D97-AF65-F5344CB8AC3E}">
-        <p14:creationId xmlns:p14="http://schemas.microsoft.com/office/powerpoint/2010/main" val="1422105800"/>
+        <p14:creationId xmlns:p14="http://schemas.microsoft.com/office/powerpoint/2010/main" val="1994569339"/>
       </p:ext>
     </p:extLst>
   </p:cSld>
@@ -4303,7 +4303,7 @@
           <p:cNvPr id="13" name="">
             <a:extLst xmlns:a="http://schemas.openxmlformats.org/drawingml/2006/main">
               <a:ext uri="{FF2B5EF4-FFF2-40B4-BE49-F238E27FC236}">
-                <a16:creationId xmlns:a16="http://schemas.microsoft.com/office/drawing/2014/main" id="{A72C5ABC-CA79-4335-AD7C-E92F9AB51CF7}"/>
+                <a16:creationId xmlns:a16="http://schemas.microsoft.com/office/drawing/2014/main" id="{95A2655D-7B76-46B5-820E-653A6112590E}"/>
               </a:ext>
             </a:extLst>
           </p:cNvPr>
@@ -4361,7 +4361,7 @@
           <p:cNvPr id="2" name="">
             <a:extLst xmlns:a="http://schemas.openxmlformats.org/drawingml/2006/main">
               <a:ext uri="{FF2B5EF4-FFF2-40B4-BE49-F238E27FC236}">
-                <a16:creationId xmlns:a16="http://schemas.microsoft.com/office/drawing/2014/main" id="{611E2E10-1AC0-471D-B6E1-051A26A778F7}"/>
+                <a16:creationId xmlns:a16="http://schemas.microsoft.com/office/drawing/2014/main" id="{05F6E342-6C7D-4221-B958-847B460BEF1C}"/>
               </a:ext>
             </a:extLst>
           </p:cNvPr>
@@ -4419,7 +4419,7 @@
           <p:cNvPr id="3" name="">
             <a:extLst xmlns:a="http://schemas.openxmlformats.org/drawingml/2006/main">
               <a:ext uri="{FF2B5EF4-FFF2-40B4-BE49-F238E27FC236}">
-                <a16:creationId xmlns:a16="http://schemas.microsoft.com/office/drawing/2014/main" id="{11F18901-BE44-4F1C-B9F2-E10F9C32E557}"/>
+                <a16:creationId xmlns:a16="http://schemas.microsoft.com/office/drawing/2014/main" id="{9823702A-7457-426B-A0CF-1BD76B23ABA8}"/>
               </a:ext>
             </a:extLst>
           </p:cNvPr>
@@ -4454,7 +4454,7 @@
           <p:cNvPr id="4" name="">
             <a:extLst xmlns:a="http://schemas.openxmlformats.org/drawingml/2006/main">
               <a:ext uri="{FF2B5EF4-FFF2-40B4-BE49-F238E27FC236}">
-                <a16:creationId xmlns:a16="http://schemas.microsoft.com/office/drawing/2014/main" id="{5328AD62-1ACA-4855-BBB9-2A060A1BE372}"/>
+                <a16:creationId xmlns:a16="http://schemas.microsoft.com/office/drawing/2014/main" id="{5CAF867B-1007-4DDE-9777-756B89E1AC4A}"/>
               </a:ext>
             </a:extLst>
           </p:cNvPr>
@@ -4512,7 +4512,7 @@
           <p:cNvPr id="5" name="">
             <a:extLst xmlns:a="http://schemas.openxmlformats.org/drawingml/2006/main">
               <a:ext uri="{FF2B5EF4-FFF2-40B4-BE49-F238E27FC236}">
-                <a16:creationId xmlns:a16="http://schemas.microsoft.com/office/drawing/2014/main" id="{B9421E58-403C-45DC-8989-8B4767BE660D}"/>
+                <a16:creationId xmlns:a16="http://schemas.microsoft.com/office/drawing/2014/main" id="{41ABDA7B-0538-4B20-B0F5-609781E08A9A}"/>
               </a:ext>
             </a:extLst>
           </p:cNvPr>
@@ -4570,7 +4570,7 @@
           <p:cNvPr id="6" name="">
             <a:extLst xmlns:a="http://schemas.openxmlformats.org/drawingml/2006/main">
               <a:ext uri="{FF2B5EF4-FFF2-40B4-BE49-F238E27FC236}">
-                <a16:creationId xmlns:a16="http://schemas.microsoft.com/office/drawing/2014/main" id="{E56D2653-6F70-4F87-A2F3-C43171829B19}"/>
+                <a16:creationId xmlns:a16="http://schemas.microsoft.com/office/drawing/2014/main" id="{FBA2F2A8-18EB-4B27-9563-19B85B801820}"/>
               </a:ext>
             </a:extLst>
           </p:cNvPr>
@@ -4605,7 +4605,7 @@
           <p:cNvPr id="7" name="">
             <a:extLst xmlns:a="http://schemas.openxmlformats.org/drawingml/2006/main">
               <a:ext uri="{FF2B5EF4-FFF2-40B4-BE49-F238E27FC236}">
-                <a16:creationId xmlns:a16="http://schemas.microsoft.com/office/drawing/2014/main" id="{DF8FDA1B-BD5E-4B06-A3F5-907E85A768AF}"/>
+                <a16:creationId xmlns:a16="http://schemas.microsoft.com/office/drawing/2014/main" id="{C5DE0680-C3CD-4D1B-A34C-73C259684DC2}"/>
               </a:ext>
             </a:extLst>
           </p:cNvPr>
@@ -4663,7 +4663,7 @@
           <p:cNvPr id="8" name="">
             <a:extLst xmlns:a="http://schemas.openxmlformats.org/drawingml/2006/main">
               <a:ext uri="{FF2B5EF4-FFF2-40B4-BE49-F238E27FC236}">
-                <a16:creationId xmlns:a16="http://schemas.microsoft.com/office/drawing/2014/main" id="{7769DBD0-E61B-4A2A-8AE8-B81C56DA976C}"/>
+                <a16:creationId xmlns:a16="http://schemas.microsoft.com/office/drawing/2014/main" id="{5EBC41F9-4536-4D29-B4C8-F6DF1CAC74F2}"/>
               </a:ext>
             </a:extLst>
           </p:cNvPr>
@@ -4721,7 +4721,7 @@
           <p:cNvPr id="9" name="">
             <a:extLst xmlns:a="http://schemas.openxmlformats.org/drawingml/2006/main">
               <a:ext uri="{FF2B5EF4-FFF2-40B4-BE49-F238E27FC236}">
-                <a16:creationId xmlns:a16="http://schemas.microsoft.com/office/drawing/2014/main" id="{47DDB6BE-2434-43EE-8307-AC26B75002A6}"/>
+                <a16:creationId xmlns:a16="http://schemas.microsoft.com/office/drawing/2014/main" id="{7BA19CB8-3D8A-4A73-8DCC-F20700F67E5A}"/>
               </a:ext>
             </a:extLst>
           </p:cNvPr>
@@ -4756,7 +4756,7 @@
           <p:cNvPr id="10" name="">
             <a:extLst xmlns:a="http://schemas.openxmlformats.org/drawingml/2006/main">
               <a:ext uri="{FF2B5EF4-FFF2-40B4-BE49-F238E27FC236}">
-                <a16:creationId xmlns:a16="http://schemas.microsoft.com/office/drawing/2014/main" id="{36E112DE-DE0A-4103-B14F-2C0F5EAE9761}"/>
+                <a16:creationId xmlns:a16="http://schemas.microsoft.com/office/drawing/2014/main" id="{01D7FECC-D1BB-4161-9E53-E3FC16ACFFDD}"/>
               </a:ext>
             </a:extLst>
           </p:cNvPr>
@@ -4814,7 +4814,7 @@
           <p:cNvPr id="11" name="">
             <a:extLst xmlns:a="http://schemas.openxmlformats.org/drawingml/2006/main">
               <a:ext uri="{FF2B5EF4-FFF2-40B4-BE49-F238E27FC236}">
-                <a16:creationId xmlns:a16="http://schemas.microsoft.com/office/drawing/2014/main" id="{D1D9C31A-4B98-4BF3-9167-A2204052BEC1}"/>
+                <a16:creationId xmlns:a16="http://schemas.microsoft.com/office/drawing/2014/main" id="{5F30A69D-960C-4827-BCBB-D73AD7C71A3A}"/>
               </a:ext>
             </a:extLst>
           </p:cNvPr>
@@ -4872,7 +4872,7 @@
           <p:cNvPr id="12" name="">
             <a:extLst xmlns:a="http://schemas.openxmlformats.org/drawingml/2006/main">
               <a:ext uri="{FF2B5EF4-FFF2-40B4-BE49-F238E27FC236}">
-                <a16:creationId xmlns:a16="http://schemas.microsoft.com/office/drawing/2014/main" id="{BDC80FB2-84CB-4991-9FF1-28E0238704F4}"/>
+                <a16:creationId xmlns:a16="http://schemas.microsoft.com/office/drawing/2014/main" id="{2C0C282E-D888-48D1-963C-96AAB35D26AB}"/>
               </a:ext>
             </a:extLst>
           </p:cNvPr>
@@ -4928,7 +4928,7 @@
     </p:spTree>
     <p:extLst>
       <p:ext uri="{BB962C8B-B14F-4D97-AF65-F5344CB8AC3E}">
-        <p14:creationId xmlns:p14="http://schemas.microsoft.com/office/powerpoint/2010/main" val="640899966"/>
+        <p14:creationId xmlns:p14="http://schemas.microsoft.com/office/powerpoint/2010/main" val="866723601"/>
       </p:ext>
     </p:extLst>
   </p:cSld>
@@ -4959,7 +4959,7 @@
           <p:cNvPr id="15" name="">
             <a:extLst xmlns:a="http://schemas.openxmlformats.org/drawingml/2006/main">
               <a:ext uri="{FF2B5EF4-FFF2-40B4-BE49-F238E27FC236}">
-                <a16:creationId xmlns:a16="http://schemas.microsoft.com/office/drawing/2014/main" id="{1C74F4E3-BD81-4D68-A953-5E3ED8DC3C9D}"/>
+                <a16:creationId xmlns:a16="http://schemas.microsoft.com/office/drawing/2014/main" id="{AC749316-A4D4-4FA1-9148-BAD8624302E7}"/>
               </a:ext>
             </a:extLst>
           </p:cNvPr>
@@ -5017,7 +5017,7 @@
           <p:cNvPr id="2" name="">
             <a:extLst xmlns:a="http://schemas.openxmlformats.org/drawingml/2006/main">
               <a:ext uri="{FF2B5EF4-FFF2-40B4-BE49-F238E27FC236}">
-                <a16:creationId xmlns:a16="http://schemas.microsoft.com/office/drawing/2014/main" id="{7C47B84C-5B53-4651-917E-C7B9828F35E9}"/>
+                <a16:creationId xmlns:a16="http://schemas.microsoft.com/office/drawing/2014/main" id="{BA6EA689-2161-440F-9A30-A2606EE37CBB}"/>
               </a:ext>
             </a:extLst>
           </p:cNvPr>
@@ -5075,7 +5075,7 @@
           <p:cNvPr id="3" name="">
             <a:extLst xmlns:a="http://schemas.openxmlformats.org/drawingml/2006/main">
               <a:ext uri="{FF2B5EF4-FFF2-40B4-BE49-F238E27FC236}">
-                <a16:creationId xmlns:a16="http://schemas.microsoft.com/office/drawing/2014/main" id="{D1A99AA2-0329-4A7F-A9BC-7B93CE8CF051}"/>
+                <a16:creationId xmlns:a16="http://schemas.microsoft.com/office/drawing/2014/main" id="{DB5E830D-9898-4BB7-A29D-F9D1A6EDE697}"/>
               </a:ext>
             </a:extLst>
           </p:cNvPr>
@@ -5110,7 +5110,7 @@
           <p:cNvPr id="4" name="">
             <a:extLst xmlns:a="http://schemas.openxmlformats.org/drawingml/2006/main">
               <a:ext uri="{FF2B5EF4-FFF2-40B4-BE49-F238E27FC236}">
-                <a16:creationId xmlns:a16="http://schemas.microsoft.com/office/drawing/2014/main" id="{CA4CDF45-B9B7-4E84-8521-A80346E12EC7}"/>
+                <a16:creationId xmlns:a16="http://schemas.microsoft.com/office/drawing/2014/main" id="{3BB5D4C2-A70A-4931-8F92-CC83FBCC8BAF}"/>
               </a:ext>
             </a:extLst>
           </p:cNvPr>
@@ -5168,7 +5168,7 @@
           <p:cNvPr id="5" name="">
             <a:extLst xmlns:a="http://schemas.openxmlformats.org/drawingml/2006/main">
               <a:ext uri="{FF2B5EF4-FFF2-40B4-BE49-F238E27FC236}">
-                <a16:creationId xmlns:a16="http://schemas.microsoft.com/office/drawing/2014/main" id="{4A68370B-CD89-4A12-8E60-552580FDE18A}"/>
+                <a16:creationId xmlns:a16="http://schemas.microsoft.com/office/drawing/2014/main" id="{7FF913F0-61B9-423F-9F48-5092A4039180}"/>
               </a:ext>
             </a:extLst>
           </p:cNvPr>
@@ -5226,7 +5226,7 @@
           <p:cNvPr id="6" name="">
             <a:extLst xmlns:a="http://schemas.openxmlformats.org/drawingml/2006/main">
               <a:ext uri="{FF2B5EF4-FFF2-40B4-BE49-F238E27FC236}">
-                <a16:creationId xmlns:a16="http://schemas.microsoft.com/office/drawing/2014/main" id="{AD1671B6-09A9-42D9-B93E-BDEB8B9EAD51}"/>
+                <a16:creationId xmlns:a16="http://schemas.microsoft.com/office/drawing/2014/main" id="{5745277E-DC09-4159-ABFE-9CDFD74F83C1}"/>
               </a:ext>
             </a:extLst>
           </p:cNvPr>
@@ -5261,7 +5261,7 @@
           <p:cNvPr id="7" name="">
             <a:extLst xmlns:a="http://schemas.openxmlformats.org/drawingml/2006/main">
               <a:ext uri="{FF2B5EF4-FFF2-40B4-BE49-F238E27FC236}">
-                <a16:creationId xmlns:a16="http://schemas.microsoft.com/office/drawing/2014/main" id="{9E0B1C6A-20DC-4389-B94C-E1CE4396B898}"/>
+                <a16:creationId xmlns:a16="http://schemas.microsoft.com/office/drawing/2014/main" id="{6981FDDC-92EF-4B6C-BFE1-005E67A8DAEF}"/>
               </a:ext>
             </a:extLst>
           </p:cNvPr>
@@ -5319,7 +5319,7 @@
           <p:cNvPr id="8" name="">
             <a:extLst xmlns:a="http://schemas.openxmlformats.org/drawingml/2006/main">
               <a:ext uri="{FF2B5EF4-FFF2-40B4-BE49-F238E27FC236}">
-                <a16:creationId xmlns:a16="http://schemas.microsoft.com/office/drawing/2014/main" id="{0BE62731-E418-4058-AEE1-1617C87A538B}"/>
+                <a16:creationId xmlns:a16="http://schemas.microsoft.com/office/drawing/2014/main" id="{66F94B7D-BF5B-4F16-99A1-9516ABBEF0BB}"/>
               </a:ext>
             </a:extLst>
           </p:cNvPr>
@@ -5377,7 +5377,7 @@
           <p:cNvPr id="9" name="">
             <a:extLst xmlns:a="http://schemas.openxmlformats.org/drawingml/2006/main">
               <a:ext uri="{FF2B5EF4-FFF2-40B4-BE49-F238E27FC236}">
-                <a16:creationId xmlns:a16="http://schemas.microsoft.com/office/drawing/2014/main" id="{93F6964B-02C4-4426-85C1-F0286E5D83BA}"/>
+                <a16:creationId xmlns:a16="http://schemas.microsoft.com/office/drawing/2014/main" id="{AE960B7F-A565-4A90-AADC-1AEAEF463C64}"/>
               </a:ext>
             </a:extLst>
           </p:cNvPr>
@@ -5412,7 +5412,7 @@
           <p:cNvPr id="10" name="">
             <a:extLst xmlns:a="http://schemas.openxmlformats.org/drawingml/2006/main">
               <a:ext uri="{FF2B5EF4-FFF2-40B4-BE49-F238E27FC236}">
-                <a16:creationId xmlns:a16="http://schemas.microsoft.com/office/drawing/2014/main" id="{FE3C38C5-24EB-4075-9A9C-4204052358E6}"/>
+                <a16:creationId xmlns:a16="http://schemas.microsoft.com/office/drawing/2014/main" id="{D879013A-A57B-4EB2-839B-758F383DCFE8}"/>
               </a:ext>
             </a:extLst>
           </p:cNvPr>
@@ -5470,7 +5470,7 @@
           <p:cNvPr id="11" name="">
             <a:extLst xmlns:a="http://schemas.openxmlformats.org/drawingml/2006/main">
               <a:ext uri="{FF2B5EF4-FFF2-40B4-BE49-F238E27FC236}">
-                <a16:creationId xmlns:a16="http://schemas.microsoft.com/office/drawing/2014/main" id="{7794A71F-DB5C-4D33-A75B-626FAEC13780}"/>
+                <a16:creationId xmlns:a16="http://schemas.microsoft.com/office/drawing/2014/main" id="{A27F628C-4D4E-40DC-83DA-10DE701D419E}"/>
               </a:ext>
             </a:extLst>
           </p:cNvPr>
@@ -5528,7 +5528,7 @@
           <p:cNvPr id="12" name="">
             <a:extLst xmlns:a="http://schemas.openxmlformats.org/drawingml/2006/main">
               <a:ext uri="{FF2B5EF4-FFF2-40B4-BE49-F238E27FC236}">
-                <a16:creationId xmlns:a16="http://schemas.microsoft.com/office/drawing/2014/main" id="{05F0733B-C0E9-4FDD-A959-6AC024760879}"/>
+                <a16:creationId xmlns:a16="http://schemas.microsoft.com/office/drawing/2014/main" id="{0A82F08D-7389-47B0-BE4F-D4D91593BF84}"/>
               </a:ext>
             </a:extLst>
           </p:cNvPr>
@@ -5563,7 +5563,7 @@
           <p:cNvPr id="13" name="">
             <a:extLst xmlns:a="http://schemas.openxmlformats.org/drawingml/2006/main">
               <a:ext uri="{FF2B5EF4-FFF2-40B4-BE49-F238E27FC236}">
-                <a16:creationId xmlns:a16="http://schemas.microsoft.com/office/drawing/2014/main" id="{61AA575F-05A1-40DA-A6B4-1ECC7155BE49}"/>
+                <a16:creationId xmlns:a16="http://schemas.microsoft.com/office/drawing/2014/main" id="{BA424D5D-9198-4AA5-88B5-FEC0EF9A4BD6}"/>
               </a:ext>
             </a:extLst>
           </p:cNvPr>
@@ -5621,7 +5621,7 @@
           <p:cNvPr id="14" name="">
             <a:extLst xmlns:a="http://schemas.openxmlformats.org/drawingml/2006/main">
               <a:ext uri="{FF2B5EF4-FFF2-40B4-BE49-F238E27FC236}">
-                <a16:creationId xmlns:a16="http://schemas.microsoft.com/office/drawing/2014/main" id="{F3A2337F-306E-409F-8764-6560B5CFAD9C}"/>
+                <a16:creationId xmlns:a16="http://schemas.microsoft.com/office/drawing/2014/main" id="{8C89DC13-11BA-4780-A0AD-CF8D138BAF17}"/>
               </a:ext>
             </a:extLst>
           </p:cNvPr>
@@ -5677,7 +5677,7 @@
     </p:spTree>
     <p:extLst>
       <p:ext uri="{BB962C8B-B14F-4D97-AF65-F5344CB8AC3E}">
-        <p14:creationId xmlns:p14="http://schemas.microsoft.com/office/powerpoint/2010/main" val="1794765103"/>
+        <p14:creationId xmlns:p14="http://schemas.microsoft.com/office/powerpoint/2010/main" val="827575271"/>
       </p:ext>
     </p:extLst>
   </p:cSld>
@@ -5708,7 +5708,7 @@
           <p:cNvPr id="23" name="">
             <a:extLst xmlns:a="http://schemas.openxmlformats.org/drawingml/2006/main">
               <a:ext uri="{FF2B5EF4-FFF2-40B4-BE49-F238E27FC236}">
-                <a16:creationId xmlns:a16="http://schemas.microsoft.com/office/drawing/2014/main" id="{23D52A9B-12F2-49A0-A85A-19683F801839}"/>
+                <a16:creationId xmlns:a16="http://schemas.microsoft.com/office/drawing/2014/main" id="{C2A1D414-622C-4816-BF82-9C98A13A1DC2}"/>
               </a:ext>
             </a:extLst>
           </p:cNvPr>
@@ -5766,7 +5766,7 @@
           <p:cNvPr id="2" name="">
             <a:extLst xmlns:a="http://schemas.openxmlformats.org/drawingml/2006/main">
               <a:ext uri="{FF2B5EF4-FFF2-40B4-BE49-F238E27FC236}">
-                <a16:creationId xmlns:a16="http://schemas.microsoft.com/office/drawing/2014/main" id="{CA86AC64-BF9D-4B4F-972F-AEEB9723011B}"/>
+                <a16:creationId xmlns:a16="http://schemas.microsoft.com/office/drawing/2014/main" id="{884D7EDE-A059-4E57-A8C3-2E50DD814E1B}"/>
               </a:ext>
             </a:extLst>
           </p:cNvPr>
@@ -5824,7 +5824,7 @@
           <p:cNvPr id="3" name="">
             <a:extLst xmlns:a="http://schemas.openxmlformats.org/drawingml/2006/main">
               <a:ext uri="{FF2B5EF4-FFF2-40B4-BE49-F238E27FC236}">
-                <a16:creationId xmlns:a16="http://schemas.microsoft.com/office/drawing/2014/main" id="{44BD5EC2-6F5A-4086-AB97-3A69C0EC7991}"/>
+                <a16:creationId xmlns:a16="http://schemas.microsoft.com/office/drawing/2014/main" id="{679F608D-E928-4815-87A7-6A728140D19B}"/>
               </a:ext>
             </a:extLst>
           </p:cNvPr>
@@ -5859,7 +5859,7 @@
           <p:cNvPr id="4" name="">
             <a:extLst xmlns:a="http://schemas.openxmlformats.org/drawingml/2006/main">
               <a:ext uri="{FF2B5EF4-FFF2-40B4-BE49-F238E27FC236}">
-                <a16:creationId xmlns:a16="http://schemas.microsoft.com/office/drawing/2014/main" id="{5BF074C4-79C9-4668-A8F2-9AE1F98CE53A}"/>
+                <a16:creationId xmlns:a16="http://schemas.microsoft.com/office/drawing/2014/main" id="{4281580D-6C53-4178-A52E-910F822A18E3}"/>
               </a:ext>
             </a:extLst>
           </p:cNvPr>
@@ -5917,7 +5917,7 @@
           <p:cNvPr id="5" name="">
             <a:extLst xmlns:a="http://schemas.openxmlformats.org/drawingml/2006/main">
               <a:ext uri="{FF2B5EF4-FFF2-40B4-BE49-F238E27FC236}">
-                <a16:creationId xmlns:a16="http://schemas.microsoft.com/office/drawing/2014/main" id="{1599AD44-6D6A-4EA7-95BA-F72386CAD92D}"/>
+                <a16:creationId xmlns:a16="http://schemas.microsoft.com/office/drawing/2014/main" id="{D6EBB25C-F4E7-4A49-A6FD-3A4397114DA5}"/>
               </a:ext>
             </a:extLst>
           </p:cNvPr>
@@ -5975,7 +5975,7 @@
           <p:cNvPr id="6" name="">
             <a:extLst xmlns:a="http://schemas.openxmlformats.org/drawingml/2006/main">
               <a:ext uri="{FF2B5EF4-FFF2-40B4-BE49-F238E27FC236}">
-                <a16:creationId xmlns:a16="http://schemas.microsoft.com/office/drawing/2014/main" id="{38E7EEBB-51CD-4848-B0F0-52E85AF0071F}"/>
+                <a16:creationId xmlns:a16="http://schemas.microsoft.com/office/drawing/2014/main" id="{A45A007F-E209-4354-AEFA-27D78C83224D}"/>
               </a:ext>
             </a:extLst>
           </p:cNvPr>
@@ -6033,7 +6033,7 @@
           <p:cNvPr id="7" name="">
             <a:extLst xmlns:a="http://schemas.openxmlformats.org/drawingml/2006/main">
               <a:ext uri="{FF2B5EF4-FFF2-40B4-BE49-F238E27FC236}">
-                <a16:creationId xmlns:a16="http://schemas.microsoft.com/office/drawing/2014/main" id="{EA4CDB47-9B48-4B8E-9EB9-4F1052EC4CB7}"/>
+                <a16:creationId xmlns:a16="http://schemas.microsoft.com/office/drawing/2014/main" id="{AEF5146F-1848-4CD7-84F7-2D979EDFEAFC}"/>
               </a:ext>
             </a:extLst>
           </p:cNvPr>
@@ -6068,7 +6068,7 @@
           <p:cNvPr id="8" name="">
             <a:extLst xmlns:a="http://schemas.openxmlformats.org/drawingml/2006/main">
               <a:ext uri="{FF2B5EF4-FFF2-40B4-BE49-F238E27FC236}">
-                <a16:creationId xmlns:a16="http://schemas.microsoft.com/office/drawing/2014/main" id="{9423D53A-2F86-4BF2-96EB-82EEFBF2B0C6}"/>
+                <a16:creationId xmlns:a16="http://schemas.microsoft.com/office/drawing/2014/main" id="{276DBA8F-EC34-48BF-AB6B-B457C64FF16C}"/>
               </a:ext>
             </a:extLst>
           </p:cNvPr>
@@ -6126,7 +6126,7 @@
           <p:cNvPr id="9" name="">
             <a:extLst xmlns:a="http://schemas.openxmlformats.org/drawingml/2006/main">
               <a:ext uri="{FF2B5EF4-FFF2-40B4-BE49-F238E27FC236}">
-                <a16:creationId xmlns:a16="http://schemas.microsoft.com/office/drawing/2014/main" id="{9CFBFCE1-822E-40C3-86B4-5ABFED4B0834}"/>
+                <a16:creationId xmlns:a16="http://schemas.microsoft.com/office/drawing/2014/main" id="{15759A13-BE0A-4AB5-826A-60E57B0FD75A}"/>
               </a:ext>
             </a:extLst>
           </p:cNvPr>
@@ -6184,7 +6184,7 @@
           <p:cNvPr id="10" name="">
             <a:extLst xmlns:a="http://schemas.openxmlformats.org/drawingml/2006/main">
               <a:ext uri="{FF2B5EF4-FFF2-40B4-BE49-F238E27FC236}">
-                <a16:creationId xmlns:a16="http://schemas.microsoft.com/office/drawing/2014/main" id="{E08C4AF2-5E6C-4353-BE81-C6CE45FF74AE}"/>
+                <a16:creationId xmlns:a16="http://schemas.microsoft.com/office/drawing/2014/main" id="{87B62400-E00D-489B-A834-31212B87F56A}"/>
               </a:ext>
             </a:extLst>
           </p:cNvPr>
@@ -6242,7 +6242,7 @@
           <p:cNvPr id="11" name="">
             <a:extLst xmlns:a="http://schemas.openxmlformats.org/drawingml/2006/main">
               <a:ext uri="{FF2B5EF4-FFF2-40B4-BE49-F238E27FC236}">
-                <a16:creationId xmlns:a16="http://schemas.microsoft.com/office/drawing/2014/main" id="{DEB6A15E-5581-4F6B-B93E-D899C726B787}"/>
+                <a16:creationId xmlns:a16="http://schemas.microsoft.com/office/drawing/2014/main" id="{8DB983DB-4AF9-48AC-B4E9-BF4C401A1184}"/>
               </a:ext>
             </a:extLst>
           </p:cNvPr>
@@ -6277,7 +6277,7 @@
           <p:cNvPr id="12" name="">
             <a:extLst xmlns:a="http://schemas.openxmlformats.org/drawingml/2006/main">
               <a:ext uri="{FF2B5EF4-FFF2-40B4-BE49-F238E27FC236}">
-                <a16:creationId xmlns:a16="http://schemas.microsoft.com/office/drawing/2014/main" id="{748880EE-60A7-45D3-88C6-64E47EEB483B}"/>
+                <a16:creationId xmlns:a16="http://schemas.microsoft.com/office/drawing/2014/main" id="{9BE4AC4A-52D7-4516-839D-4663D2477BF9}"/>
               </a:ext>
             </a:extLst>
           </p:cNvPr>
@@ -6335,7 +6335,7 @@
           <p:cNvPr id="13" name="">
             <a:extLst xmlns:a="http://schemas.openxmlformats.org/drawingml/2006/main">
               <a:ext uri="{FF2B5EF4-FFF2-40B4-BE49-F238E27FC236}">
-                <a16:creationId xmlns:a16="http://schemas.microsoft.com/office/drawing/2014/main" id="{7F06A914-71D7-4FF7-B006-0427EDE54054}"/>
+                <a16:creationId xmlns:a16="http://schemas.microsoft.com/office/drawing/2014/main" id="{8D5F964C-A5CE-4863-8F52-A2025CF911FA}"/>
               </a:ext>
             </a:extLst>
           </p:cNvPr>
@@ -6393,7 +6393,7 @@
           <p:cNvPr id="14" name="">
             <a:extLst xmlns:a="http://schemas.openxmlformats.org/drawingml/2006/main">
               <a:ext uri="{FF2B5EF4-FFF2-40B4-BE49-F238E27FC236}">
-                <a16:creationId xmlns:a16="http://schemas.microsoft.com/office/drawing/2014/main" id="{3CE41ED0-4320-4845-94CA-910630629E48}"/>
+                <a16:creationId xmlns:a16="http://schemas.microsoft.com/office/drawing/2014/main" id="{547FE8F1-D277-4B30-806C-7E06FDCE2240}"/>
               </a:ext>
             </a:extLst>
           </p:cNvPr>
@@ -6451,7 +6451,7 @@
           <p:cNvPr id="15" name="">
             <a:extLst xmlns:a="http://schemas.openxmlformats.org/drawingml/2006/main">
               <a:ext uri="{FF2B5EF4-FFF2-40B4-BE49-F238E27FC236}">
-                <a16:creationId xmlns:a16="http://schemas.microsoft.com/office/drawing/2014/main" id="{10B8915F-3462-4950-884E-2E12C6A3A6E4}"/>
+                <a16:creationId xmlns:a16="http://schemas.microsoft.com/office/drawing/2014/main" id="{628303FE-8046-4862-9B18-78E34784BBF8}"/>
               </a:ext>
             </a:extLst>
           </p:cNvPr>
@@ -6486,7 +6486,7 @@
           <p:cNvPr id="16" name="">
             <a:extLst xmlns:a="http://schemas.openxmlformats.org/drawingml/2006/main">
               <a:ext uri="{FF2B5EF4-FFF2-40B4-BE49-F238E27FC236}">
-                <a16:creationId xmlns:a16="http://schemas.microsoft.com/office/drawing/2014/main" id="{8497E934-A7DA-4423-A7B5-9B9F0FF9CF21}"/>
+                <a16:creationId xmlns:a16="http://schemas.microsoft.com/office/drawing/2014/main" id="{7E20A5B1-75ED-49AE-AE19-AC975162458E}"/>
               </a:ext>
             </a:extLst>
           </p:cNvPr>
@@ -6544,7 +6544,7 @@
           <p:cNvPr id="17" name="">
             <a:extLst xmlns:a="http://schemas.openxmlformats.org/drawingml/2006/main">
               <a:ext uri="{FF2B5EF4-FFF2-40B4-BE49-F238E27FC236}">
-                <a16:creationId xmlns:a16="http://schemas.microsoft.com/office/drawing/2014/main" id="{2CFA4A91-F9EE-4DBD-AAA3-658421AEF694}"/>
+                <a16:creationId xmlns:a16="http://schemas.microsoft.com/office/drawing/2014/main" id="{9515915B-6298-4978-97A6-2E82CE1A9EBA}"/>
               </a:ext>
             </a:extLst>
           </p:cNvPr>
@@ -6602,7 +6602,7 @@
           <p:cNvPr id="18" name="">
             <a:extLst xmlns:a="http://schemas.openxmlformats.org/drawingml/2006/main">
               <a:ext uri="{FF2B5EF4-FFF2-40B4-BE49-F238E27FC236}">
-                <a16:creationId xmlns:a16="http://schemas.microsoft.com/office/drawing/2014/main" id="{37FAAAB4-55FD-4D93-8313-76681D33F606}"/>
+                <a16:creationId xmlns:a16="http://schemas.microsoft.com/office/drawing/2014/main" id="{AF410D7D-A52C-4239-AD9D-4289963FF4F9}"/>
               </a:ext>
             </a:extLst>
           </p:cNvPr>
@@ -6660,7 +6660,7 @@
           <p:cNvPr id="19" name="">
             <a:extLst xmlns:a="http://schemas.openxmlformats.org/drawingml/2006/main">
               <a:ext uri="{FF2B5EF4-FFF2-40B4-BE49-F238E27FC236}">
-                <a16:creationId xmlns:a16="http://schemas.microsoft.com/office/drawing/2014/main" id="{83DED850-CE71-4DE7-9C3E-21EEE1E097F7}"/>
+                <a16:creationId xmlns:a16="http://schemas.microsoft.com/office/drawing/2014/main" id="{6F71561B-92B3-4F8E-A22D-D446D6948EE4}"/>
               </a:ext>
             </a:extLst>
           </p:cNvPr>
@@ -6695,7 +6695,7 @@
           <p:cNvPr id="20" name="">
             <a:extLst xmlns:a="http://schemas.openxmlformats.org/drawingml/2006/main">
               <a:ext uri="{FF2B5EF4-FFF2-40B4-BE49-F238E27FC236}">
-                <a16:creationId xmlns:a16="http://schemas.microsoft.com/office/drawing/2014/main" id="{51DE9929-5108-418E-AF99-6923076381FD}"/>
+                <a16:creationId xmlns:a16="http://schemas.microsoft.com/office/drawing/2014/main" id="{72537055-D742-4813-ADF4-F95ACB20A29C}"/>
               </a:ext>
             </a:extLst>
           </p:cNvPr>
@@ -6753,7 +6753,7 @@
           <p:cNvPr id="21" name="">
             <a:extLst xmlns:a="http://schemas.openxmlformats.org/drawingml/2006/main">
               <a:ext uri="{FF2B5EF4-FFF2-40B4-BE49-F238E27FC236}">
-                <a16:creationId xmlns:a16="http://schemas.microsoft.com/office/drawing/2014/main" id="{8A0C4120-F3D2-4E5B-8445-978139D87029}"/>
+                <a16:creationId xmlns:a16="http://schemas.microsoft.com/office/drawing/2014/main" id="{94C1813F-572D-4D17-8B0D-EC3ACE3ED716}"/>
               </a:ext>
             </a:extLst>
           </p:cNvPr>
@@ -6811,7 +6811,7 @@
           <p:cNvPr id="22" name="">
             <a:extLst xmlns:a="http://schemas.openxmlformats.org/drawingml/2006/main">
               <a:ext uri="{FF2B5EF4-FFF2-40B4-BE49-F238E27FC236}">
-                <a16:creationId xmlns:a16="http://schemas.microsoft.com/office/drawing/2014/main" id="{98FFB252-B7B5-440F-9284-9280EE07716E}"/>
+                <a16:creationId xmlns:a16="http://schemas.microsoft.com/office/drawing/2014/main" id="{B1372B6C-C502-4128-8E50-6B82939656F6}"/>
               </a:ext>
             </a:extLst>
           </p:cNvPr>
@@ -6867,7 +6867,7 @@
     </p:spTree>
     <p:extLst>
       <p:ext uri="{BB962C8B-B14F-4D97-AF65-F5344CB8AC3E}">
-        <p14:creationId xmlns:p14="http://schemas.microsoft.com/office/powerpoint/2010/main" val="597625310"/>
+        <p14:creationId xmlns:p14="http://schemas.microsoft.com/office/powerpoint/2010/main" val="639331145"/>
       </p:ext>
     </p:extLst>
   </p:cSld>
@@ -6898,7 +6898,7 @@
           <p:cNvPr id="12" name="">
             <a:extLst xmlns:a="http://schemas.openxmlformats.org/drawingml/2006/main">
               <a:ext uri="{FF2B5EF4-FFF2-40B4-BE49-F238E27FC236}">
-                <a16:creationId xmlns:a16="http://schemas.microsoft.com/office/drawing/2014/main" id="{A3E3F947-0AC6-4A99-AF48-05A355151781}"/>
+                <a16:creationId xmlns:a16="http://schemas.microsoft.com/office/drawing/2014/main" id="{9B20B05E-2E00-431C-8D04-7295ED6E223A}"/>
               </a:ext>
             </a:extLst>
           </p:cNvPr>
@@ -6956,7 +6956,7 @@
           <p:cNvPr id="2" name="">
             <a:extLst xmlns:a="http://schemas.openxmlformats.org/drawingml/2006/main">
               <a:ext uri="{FF2B5EF4-FFF2-40B4-BE49-F238E27FC236}">
-                <a16:creationId xmlns:a16="http://schemas.microsoft.com/office/drawing/2014/main" id="{E412F193-D1E8-4158-B402-58B646EA0975}"/>
+                <a16:creationId xmlns:a16="http://schemas.microsoft.com/office/drawing/2014/main" id="{F6CE9C81-25AC-4042-8B61-F73B82A2618F}"/>
               </a:ext>
             </a:extLst>
           </p:cNvPr>
@@ -7014,7 +7014,7 @@
           <p:cNvPr id="3" name="">
             <a:extLst xmlns:a="http://schemas.openxmlformats.org/drawingml/2006/main">
               <a:ext uri="{FF2B5EF4-FFF2-40B4-BE49-F238E27FC236}">
-                <a16:creationId xmlns:a16="http://schemas.microsoft.com/office/drawing/2014/main" id="{C15D4022-44A6-4801-A270-EBCC7A4E5AC8}"/>
+                <a16:creationId xmlns:a16="http://schemas.microsoft.com/office/drawing/2014/main" id="{1B518B40-B2DF-40B6-8B1F-48B5A8317E36}"/>
               </a:ext>
             </a:extLst>
           </p:cNvPr>
@@ -7049,7 +7049,7 @@
           <p:cNvPr id="4" name="">
             <a:extLst xmlns:a="http://schemas.openxmlformats.org/drawingml/2006/main">
               <a:ext uri="{FF2B5EF4-FFF2-40B4-BE49-F238E27FC236}">
-                <a16:creationId xmlns:a16="http://schemas.microsoft.com/office/drawing/2014/main" id="{2183815D-0D06-45BE-B1A3-09A31237AF5D}"/>
+                <a16:creationId xmlns:a16="http://schemas.microsoft.com/office/drawing/2014/main" id="{681D403D-9E4D-4CAA-94F3-DE96481D41A3}"/>
               </a:ext>
             </a:extLst>
           </p:cNvPr>
@@ -7107,7 +7107,7 @@
           <p:cNvPr id="5" name="">
             <a:extLst xmlns:a="http://schemas.openxmlformats.org/drawingml/2006/main">
               <a:ext uri="{FF2B5EF4-FFF2-40B4-BE49-F238E27FC236}">
-                <a16:creationId xmlns:a16="http://schemas.microsoft.com/office/drawing/2014/main" id="{F8D6C00C-80FD-4F95-9708-A89362D84B8A}"/>
+                <a16:creationId xmlns:a16="http://schemas.microsoft.com/office/drawing/2014/main" id="{A318B176-F486-4615-9594-60859F00843A}"/>
               </a:ext>
             </a:extLst>
           </p:cNvPr>
@@ -7165,7 +7165,7 @@
           <p:cNvPr id="6" name="">
             <a:extLst xmlns:a="http://schemas.openxmlformats.org/drawingml/2006/main">
               <a:ext uri="{FF2B5EF4-FFF2-40B4-BE49-F238E27FC236}">
-                <a16:creationId xmlns:a16="http://schemas.microsoft.com/office/drawing/2014/main" id="{D7CE0967-9FB5-4B74-8A4C-F8E9E9FD6B87}"/>
+                <a16:creationId xmlns:a16="http://schemas.microsoft.com/office/drawing/2014/main" id="{93F18D8E-3D89-456E-A8C1-D0F544ECFC6D}"/>
               </a:ext>
             </a:extLst>
           </p:cNvPr>
@@ -7200,7 +7200,7 @@
           <p:cNvPr id="7" name="">
             <a:extLst xmlns:a="http://schemas.openxmlformats.org/drawingml/2006/main">
               <a:ext uri="{FF2B5EF4-FFF2-40B4-BE49-F238E27FC236}">
-                <a16:creationId xmlns:a16="http://schemas.microsoft.com/office/drawing/2014/main" id="{784BFFAB-A9D9-4704-9E87-96FBD035600E}"/>
+                <a16:creationId xmlns:a16="http://schemas.microsoft.com/office/drawing/2014/main" id="{EB71CD7E-BFEF-463F-8DC9-DD09D25B0DFD}"/>
               </a:ext>
             </a:extLst>
           </p:cNvPr>
@@ -7258,7 +7258,7 @@
           <p:cNvPr id="8" name="">
             <a:extLst xmlns:a="http://schemas.openxmlformats.org/drawingml/2006/main">
               <a:ext uri="{FF2B5EF4-FFF2-40B4-BE49-F238E27FC236}">
-                <a16:creationId xmlns:a16="http://schemas.microsoft.com/office/drawing/2014/main" id="{3F84BE3C-B553-4C8D-BBE8-5F895EE3FEFD}"/>
+                <a16:creationId xmlns:a16="http://schemas.microsoft.com/office/drawing/2014/main" id="{ACFBDE91-CEFD-4CC9-BC80-C18B37CC9598}"/>
               </a:ext>
             </a:extLst>
           </p:cNvPr>
@@ -7316,7 +7316,7 @@
           <p:cNvPr id="9" name="">
             <a:extLst xmlns:a="http://schemas.openxmlformats.org/drawingml/2006/main">
               <a:ext uri="{FF2B5EF4-FFF2-40B4-BE49-F238E27FC236}">
-                <a16:creationId xmlns:a16="http://schemas.microsoft.com/office/drawing/2014/main" id="{9691F46B-F7BA-4ED0-A942-5F7B7B561CF0}"/>
+                <a16:creationId xmlns:a16="http://schemas.microsoft.com/office/drawing/2014/main" id="{8558ACAB-9C95-464C-B70A-2BC0EA5CCA89}"/>
               </a:ext>
             </a:extLst>
           </p:cNvPr>
@@ -7351,7 +7351,7 @@
           <p:cNvPr id="10" name="">
             <a:extLst xmlns:a="http://schemas.openxmlformats.org/drawingml/2006/main">
               <a:ext uri="{FF2B5EF4-FFF2-40B4-BE49-F238E27FC236}">
-                <a16:creationId xmlns:a16="http://schemas.microsoft.com/office/drawing/2014/main" id="{AE463F0D-6E55-4474-8474-542E447C9676}"/>
+                <a16:creationId xmlns:a16="http://schemas.microsoft.com/office/drawing/2014/main" id="{DDC7B76F-3DE0-4590-A3B4-57DBDCDF35F0}"/>
               </a:ext>
             </a:extLst>
           </p:cNvPr>
@@ -7409,7 +7409,7 @@
           <p:cNvPr id="11" name="">
             <a:extLst xmlns:a="http://schemas.openxmlformats.org/drawingml/2006/main">
               <a:ext uri="{FF2B5EF4-FFF2-40B4-BE49-F238E27FC236}">
-                <a16:creationId xmlns:a16="http://schemas.microsoft.com/office/drawing/2014/main" id="{1AC393C1-3C9F-4D71-AE24-256694200CB2}"/>
+                <a16:creationId xmlns:a16="http://schemas.microsoft.com/office/drawing/2014/main" id="{AC95BBDA-224F-4633-BE6B-9B55282D3170}"/>
               </a:ext>
             </a:extLst>
           </p:cNvPr>
@@ -7465,7 +7465,7 @@
     </p:spTree>
     <p:extLst>
       <p:ext uri="{BB962C8B-B14F-4D97-AF65-F5344CB8AC3E}">
-        <p14:creationId xmlns:p14="http://schemas.microsoft.com/office/powerpoint/2010/main" val="1412555322"/>
+        <p14:creationId xmlns:p14="http://schemas.microsoft.com/office/powerpoint/2010/main" val="1464482687"/>
       </p:ext>
     </p:extLst>
   </p:cSld>
@@ -7496,7 +7496,7 @@
           <p:cNvPr id="8" name="">
             <a:extLst xmlns:a="http://schemas.openxmlformats.org/drawingml/2006/main">
               <a:ext uri="{FF2B5EF4-FFF2-40B4-BE49-F238E27FC236}">
-                <a16:creationId xmlns:a16="http://schemas.microsoft.com/office/drawing/2014/main" id="{7CE7AF29-6D98-4274-B677-2A44CFE30929}"/>
+                <a16:creationId xmlns:a16="http://schemas.microsoft.com/office/drawing/2014/main" id="{67AF04DA-1910-4611-8883-DE469B189451}"/>
               </a:ext>
             </a:extLst>
           </p:cNvPr>
@@ -7554,7 +7554,7 @@
           <p:cNvPr id="2" name="">
             <a:extLst xmlns:a="http://schemas.openxmlformats.org/drawingml/2006/main">
               <a:ext uri="{FF2B5EF4-FFF2-40B4-BE49-F238E27FC236}">
-                <a16:creationId xmlns:a16="http://schemas.microsoft.com/office/drawing/2014/main" id="{41E6D872-2C60-4093-9349-BD0B26E76578}"/>
+                <a16:creationId xmlns:a16="http://schemas.microsoft.com/office/drawing/2014/main" id="{010CF6BD-8D74-49D5-B9C9-118CBC755980}"/>
               </a:ext>
             </a:extLst>
           </p:cNvPr>
@@ -7612,7 +7612,7 @@
           <p:cNvPr id="3" name="">
             <a:extLst xmlns:a="http://schemas.openxmlformats.org/drawingml/2006/main">
               <a:ext uri="{FF2B5EF4-FFF2-40B4-BE49-F238E27FC236}">
-                <a16:creationId xmlns:a16="http://schemas.microsoft.com/office/drawing/2014/main" id="{7BAFF7DB-54CA-4E24-B2BF-9F4759044B3B}"/>
+                <a16:creationId xmlns:a16="http://schemas.microsoft.com/office/drawing/2014/main" id="{24EA95FD-C51D-48AF-B42E-8FACF3253425}"/>
               </a:ext>
             </a:extLst>
           </p:cNvPr>
@@ -7670,7 +7670,7 @@
           <p:cNvPr id="4" name="">
             <a:extLst xmlns:a="http://schemas.openxmlformats.org/drawingml/2006/main">
               <a:ext uri="{FF2B5EF4-FFF2-40B4-BE49-F238E27FC236}">
-                <a16:creationId xmlns:a16="http://schemas.microsoft.com/office/drawing/2014/main" id="{32787D72-563C-487B-9E27-70D76C0512DF}"/>
+                <a16:creationId xmlns:a16="http://schemas.microsoft.com/office/drawing/2014/main" id="{3C0B4C8B-14DE-45E3-A9E9-7BDF691983AF}"/>
               </a:ext>
             </a:extLst>
           </p:cNvPr>
@@ -7705,7 +7705,7 @@
           <p:cNvPr id="5" name="">
             <a:extLst xmlns:a="http://schemas.openxmlformats.org/drawingml/2006/main">
               <a:ext uri="{FF2B5EF4-FFF2-40B4-BE49-F238E27FC236}">
-                <a16:creationId xmlns:a16="http://schemas.microsoft.com/office/drawing/2014/main" id="{1392828F-14E2-48D5-9B55-73B769F3B583}"/>
+                <a16:creationId xmlns:a16="http://schemas.microsoft.com/office/drawing/2014/main" id="{79F87129-484F-4817-B099-B0B702EF98B4}"/>
               </a:ext>
             </a:extLst>
           </p:cNvPr>
@@ -7763,7 +7763,7 @@
           <p:cNvPr id="6" name="">
             <a:extLst xmlns:a="http://schemas.openxmlformats.org/drawingml/2006/main">
               <a:ext uri="{FF2B5EF4-FFF2-40B4-BE49-F238E27FC236}">
-                <a16:creationId xmlns:a16="http://schemas.microsoft.com/office/drawing/2014/main" id="{DDB9BCAB-0168-4E88-914B-834A28C04AF2}"/>
+                <a16:creationId xmlns:a16="http://schemas.microsoft.com/office/drawing/2014/main" id="{6DD5C550-4A4A-4D19-B017-0229DA8B6FC2}"/>
               </a:ext>
             </a:extLst>
           </p:cNvPr>
@@ -7821,7 +7821,7 @@
           <p:cNvPr id="7" name="">
             <a:extLst xmlns:a="http://schemas.openxmlformats.org/drawingml/2006/main">
               <a:ext uri="{FF2B5EF4-FFF2-40B4-BE49-F238E27FC236}">
-                <a16:creationId xmlns:a16="http://schemas.microsoft.com/office/drawing/2014/main" id="{D38FDD52-A929-405E-B64D-90454AE9F17C}"/>
+                <a16:creationId xmlns:a16="http://schemas.microsoft.com/office/drawing/2014/main" id="{94381311-F4FC-44C1-8AA9-FD9C3BDA060C}"/>
               </a:ext>
             </a:extLst>
           </p:cNvPr>
@@ -7877,7 +7877,7 @@
     </p:spTree>
     <p:extLst>
       <p:ext uri="{BB962C8B-B14F-4D97-AF65-F5344CB8AC3E}">
-        <p14:creationId xmlns:p14="http://schemas.microsoft.com/office/powerpoint/2010/main" val="1262001784"/>
+        <p14:creationId xmlns:p14="http://schemas.microsoft.com/office/powerpoint/2010/main" val="1079592033"/>
       </p:ext>
     </p:extLst>
   </p:cSld>

</xml_diff>